<commit_message>
Add per-folder READMEs and pipeline guide; remove em dashes; plainer wording
</commit_message>
<xml_diff>
--- a/data/outputs/fmcg_newsletter_20260621.pptx
+++ b/data/outputs/fmcg_newsletter_20260621.pptx
@@ -3222,7 +3222,7 @@
               <a:defRPr sz="1600"/>
             </a:pPr>
             <a:r>
-              <a:t>This edition tracks 21 fast-moving consumer goods deals reported over the last 14 days. The lead stories below are ranked by a blend of relevance, source credibility and recency; a longer tail of smaller moves follows.</a:t>
+              <a:t>This edition tracks 21 FMCG deals reported over the last 14 days. Lead stories are ranked by relevance, credibility and recency.</a:t>
             </a:r>
           </a:p>
           <a:p>
@@ -3234,7 +3234,7 @@
               </a:defRPr>
             </a:pPr>
             <a:r>
-              <a:t>•  21 relevant FMCG deals surfaced from 30 raw articles</a:t>
+              <a:t>•  21 relevant FMCG deals from 30 raw articles</a:t>
             </a:r>
           </a:p>
           <a:p>
@@ -3246,7 +3246,7 @@
               </a:defRPr>
             </a:pPr>
             <a:r>
-              <a:t>•  5 duplicate/near-duplicate reports merged</a:t>
+              <a:t>•  5 duplicate reports merged</a:t>
             </a:r>
           </a:p>
           <a:p>
@@ -3270,7 +3270,7 @@
               </a:defRPr>
             </a:pPr>
             <a:r>
-              <a:t>•  Deal mix — Acquisition (13), Investment (3), Divestiture (2), Funding round (2)</a:t>
+              <a:t>•  Deal mix - Acquisition (13), Investment (3), Divestiture (2), Funding round (2)</a:t>
             </a:r>
           </a:p>
         </p:txBody>
@@ -4283,7 +4283,7 @@
               </a:defRPr>
             </a:pPr>
             <a:r>
-              <a:t>•  Ingestion: public RSS/Atom feeds (Google News deal queries + FMCG trade press), filtered to the last 14 days. No paywalled or private sources.</a:t>
+              <a:t>•  Ingestion: public RSS/Atom feeds (Google News + FMCG trade press), last 14 days.</a:t>
             </a:r>
           </a:p>
           <a:p>
@@ -4295,7 +4295,7 @@
               </a:defRPr>
             </a:pPr>
             <a:r>
-              <a:t>•  De-duplication: exact match on normalised URL/title, then near-duplicate clustering. Each story is fingerprinted by its named entities (companies, brands) and figures plus significant content words; two reports merge when they share at least 2 entities AND their blended overlap (entity + content overlap coefficients) reaches 0.50. The most credible/recent report is kept as the representative. 5 of 30 articles merged this run.</a:t>
+              <a:t>•  De-duplication: exact URL/title match, then near-dup clustering by entity overlap (threshold 0.5). 5 of 30 articles merged.</a:t>
             </a:r>
           </a:p>
           <a:p>
@@ -4307,7 +4307,7 @@
               </a:defRPr>
             </a:pPr>
             <a:r>
-              <a:t>•  Relevance: an item must show BOTH a deal signal (acquire/merger/stake/funding…) and an FMCG signal (category or named consumer-goods company); title matches weighted x2. Items scoring below 35/100 are dropped from the draft.</a:t>
+              <a:t>•  Relevance: requires a deal signal AND an FMCG signal (title ×2). Items below 35/100 are dropped.</a:t>
             </a:r>
           </a:p>
           <a:p>
@@ -4319,7 +4319,7 @@
               </a:defRPr>
             </a:pPr>
             <a:r>
-              <a:t>•  Credibility: transparent source-tier allow-list (global wire &gt; trade press &gt; general &gt; press-release wires), plus a corroboration bonus when multiple independent outlets report the same deal, and a penalty for lone press releases. We rate the SOURCE, not each claim.</a:t>
+              <a:t>•  Credibility: source-tier allow-list + corroboration bonus − lone press-release penalty.</a:t>
             </a:r>
           </a:p>
           <a:p>
@@ -4331,7 +4331,7 @@
               </a:defRPr>
             </a:pPr>
             <a:r>
-              <a:t>•  Ranking: composite of relevance (45%), credibility (30%), recency (15%) and corroboration (10%).</a:t>
+              <a:t>•  Ranking: relevance 45%, credibility 30%, recency 15%, corroboration 10%.</a:t>
             </a:r>
           </a:p>
           <a:p>
@@ -4343,7 +4343,7 @@
               </a:defRPr>
             </a:pPr>
             <a:r>
-              <a:t>•  Summaries: template-generated from extracted deal facts + the source blurb (no LLM key set).</a:t>
+              <a:t>•  Summaries: template from extracted deal facts + source blurb (no LLM_API_KEY set).</a:t>
             </a:r>
           </a:p>
           <a:p>
@@ -4355,7 +4355,7 @@
               </a:defRPr>
             </a:pPr>
             <a:r>
-              <a:t>•  Assumptions &amp; limits: deal value/parties are extracted heuristically (regex) and may be incomplete; coverage reflects what public feeds surface; this is decision-support, not advice.</a:t>
+              <a:t>•  Deal value/parties are regex heuristics and may be incomplete. Decision-support only.</a:t>
             </a:r>
           </a:p>
         </p:txBody>

</xml_diff>